<commit_message>
Slides: session 17 vaccination; other sessions in progress
Co-Authored-By: Claude Opus 5.5 <noreply@anthropic.com>
Claude-Session: https://claude.ai/code/session_01XkzKv8pUGMF9AsqSCMpnBq
</commit_message>
<xml_diff>
--- a/slides/decks/s04-mobilisation-collection.pptx
+++ b/slides/decks/s04-mobilisation-collection.pptx
@@ -132,13 +132,13 @@
   <p:extLst>
     <p:ext uri="{521415D9-36F7-43E2-AB2F-B90AF26B5E84}">
       <p14:sectionLst xmlns:p14="http://schemas.microsoft.com/office/powerpoint/2010/main">
-        <p14:section name="Opening" id="{4d83fcf3-a702-1585-321e-eae1d373a008}">
+        <p14:section name="Opening" id="{da2a56c5-b8a7-93ed-356c-9c0b052d31ab}">
           <p14:sldIdLst>
             <p14:sldId id="256"/>
             <p14:sldId id="257"/>
           </p14:sldIdLst>
         </p14:section>
-        <p14:section name="Bone marrow harvest" id="{716b030b-8342-96f4-d242-957dae5fffdd}">
+        <p14:section name="Bone marrow harvest" id="{757acd5d-d222-59f2-9d75-33221843e464}">
           <p14:sldIdLst>
             <p14:sldId id="258"/>
             <p14:sldId id="259"/>
@@ -146,7 +146,7 @@
             <p14:sldId id="261"/>
           </p14:sldIdLst>
         </p14:section>
-        <p14:section name="Mobilisation and apheresis" id="{e00f1a4d-48bd-c98a-8bab-5121cf1b0ee8}">
+        <p14:section name="Mobilisation and apheresis" id="{e2f837b7-75fa-b493-d95b-a81a65c7524c}">
           <p14:sldIdLst>
             <p14:sldId id="262"/>
             <p14:sldId id="263"/>
@@ -154,7 +154,7 @@
             <p14:sldId id="265"/>
           </p14:sldIdLst>
         </p14:section>
-        <p14:section name="Poor mobilisers, freezing and release" id="{d41a7d54-bf41-c3b4-bef7-fc3ea6c441d3}">
+        <p14:section name="Poor mobilisers, freezing and release" id="{ab361bbf-4a15-15af-c93e-9c9a6af14d20}">
           <p14:sldIdLst>
             <p14:sldId id="266"/>
             <p14:sldId id="267"/>
@@ -163,7 +163,7 @@
             <p14:sldId id="270"/>
           </p14:sldIdLst>
         </p14:section>
-        <p14:section name="Board questions" id="{3374c21b-ab55-af69-1cff-f06bf0febfc1}">
+        <p14:section name="Board questions" id="{a3458912-8e2e-5813-c529-ffb96a580f6f}">
           <p14:sldIdLst>
             <p14:sldId id="271"/>
             <p14:sldId id="272"/>
@@ -173,13 +173,13 @@
             <p14:sldId id="276"/>
           </p14:sldIdLst>
         </p14:section>
-        <p14:section name="References" id="{19f48340-6d79-8e0a-7284-4eeaac17cf44}">
+        <p14:section name="References" id="{89389930-ab0d-135f-7910-f638997683c6}">
           <p14:sldIdLst>
             <p14:sldId id="277"/>
             <p14:sldId id="278"/>
           </p14:sldIdLst>
         </p14:section>
-        <p14:section name="Backup" id="{c96c96c9-bae4-90ca-7878-736122ab90f8}">
+        <p14:section name="Backup" id="{c0a2ae86-ad4a-6864-badc-05fb21ed5c6f}">
           <p14:sldIdLst>
             <p14:sldId id="279"/>
             <p14:sldId id="280"/>
@@ -606,7 +606,7 @@
             </a:pPr>
             <a:r>
               <a:rPr lang="en-US" dirty="0"/>
-              <a:t>各位好，第 4 堂談幹細胞怎麼收、怎麼處理。核心是 Handbook 第 16 章 mobilisation and collection，加上第 15 章 bone marrow harvest 和第 20 章 cryopreservation 與 quality control。這一堂幾乎全是數字，最後三題收尾。</a:t>
+              <a:t>各位好，第 4 堂談幹細胞怎麼收、怎麼處理。核心是 Handbook 第 16 章 mobilisation and collection，加上第 15 章 bone marrow harvest 和第 20 章 cryopreservation 與 quality control。這一堂幾乎全是數字，CD34 的門檻、plerixafor 的切點、冷凍和放行的條件，都是直接出題的地方。最後用三題收尾。</a:t>
             </a:r>
           </a:p>
         </p:txBody>
@@ -745,6 +745,17 @@
               <a:t>要跑多久，可以用周邊血 CD34 和 collection efficiency，也就是 CE2，代入演算法預估。實務上，前一天的 CD34 數值不只決定要不要收，也決定今天要跑幾倍血量。兩次、三次這兩個上限，也是判斷 mobilisation 失敗的時間點。</a:t>
             </a:r>
           </a:p>
+          <a:p>
+            <a:pPr>
+              <a:spcAft>
+                <a:spcPts val="600"/>
+              </a:spcAft>
+            </a:pPr>
+            <a:r>
+              <a:rPr lang="en-US" dirty="0"/>
+              <a:t>Steady state 第三次 apheresis 還收不到目標就很難成功，和這裡連續三次的上限互相呼應。遇到這種情況，下一步不是再多跑幾次，而是回到 plerixafor 的決策，就是下一段的內容。</a:t>
+            </a:r>
+          </a:p>
         </p:txBody>
       </p:sp>
       <p:sp>
@@ -881,6 +892,17 @@
               <a:t>20、10 和三分之一這三個數字是這張的重點，考題常給第 5 天的 CD34 問下一步。加了 plerixafor，apheresis 時間短、處理血量少、第一次就收得多，總成本反而下降。2023 年 EMA 核准了第一個 plerixafor biosimilar。</a:t>
             </a:r>
           </a:p>
+          <a:p>
+            <a:pPr>
+              <a:spcAft>
+                <a:spcPts val="600"/>
+              </a:spcAft>
+            </a:pPr>
+            <a:r>
+              <a:rPr lang="en-US" dirty="0"/>
+              <a:t>劑量依體重計算，0.24 mg/kg；固定 20 mg 只適用 83 公斤以下的成人。灰色地帶要考慮的疾病和治療史，就是下一張 Table 16.3 的危險因子。</a:t>
+            </a:r>
+          </a:p>
         </p:txBody>
       </p:sp>
       <p:sp>
@@ -1017,6 +1039,17 @@
               <a:t>有一個以上 risk factor 的病人，書上建議考慮 preemptive plerixafor，不要等到失敗才補救。注意表上寫 60 歲、內文寫 65 歲，是兩個不同的問題。</a:t>
             </a:r>
           </a:p>
+          <a:p>
+            <a:pPr>
+              <a:spcAft>
+                <a:spcPts val="600"/>
+              </a:spcAft>
+            </a:pPr>
+            <a:r>
+              <a:rPr lang="en-US" dirty="0"/>
+              <a:t>這張表也可以反過來用。病人如果有好幾個危險因子，例如年紀大、用過 lenalidomide、血小板偏低，即使第 5 天的 CD34 落在 10 到 20 的灰色地帶，也比較傾向直接加 plerixafor。</a:t>
+            </a:r>
+          </a:p>
         </p:txBody>
       </p:sp>
       <p:sp>
@@ -1142,6 +1175,17 @@
               <a:t>右邊是很多人擔心的問題，poor mobiliser 收到的細胞品質會不會比較差。第 20 章的答案是不會，primitive 和 quiescent 的 CD34 亞群比例相同，移植後白血球和血小板恢復也沒有差別。加了 plerixafor 的 graft 會有比較多 primitive HSC 和淋巴球，包括 T、B、NK 細胞，但這些差異沒有轉化成臨床差別。</a:t>
             </a:r>
           </a:p>
+          <a:p>
+            <a:pPr>
+              <a:spcAft>
+                <a:spcPts val="600"/>
+              </a:spcAft>
+            </a:pPr>
+            <a:r>
+              <a:rPr lang="en-US" dirty="0"/>
+              <a:t>第 16 章最後提到，除了 CD34，graft 裡的其他細胞亞群也可能影響免疫重建，mobilisation 的方式可能改變 graft 的免疫組成。這部分還在研究階段，目前 CD34 仍是最重要的品質指標。</a:t>
+            </a:r>
+          </a:p>
         </p:txBody>
       </p:sp>
       <p:sp>
@@ -1278,6 +1322,17 @@
               <a:t>在這種條件下，CD34 細胞可以存活到 19 年，冷凍多久也不影響血球恢復。72 小時、負 140 度、20 分鐘，這三個數字最常考。</a:t>
             </a:r>
           </a:p>
+          <a:p>
+            <a:pPr>
+              <a:spcAft>
+                <a:spcPts val="600"/>
+              </a:spcAft>
+            </a:pPr>
+            <a:r>
+              <a:rPr lang="en-US" dirty="0"/>
+              <a:t>收集到冷凍的時間和細胞濃度是一組，放得越久，濃度上限越低，兩個數字要一起記。整個流程要依各國主管機關和歐盟 directive 等規範執行，各中心的 protocol 不完全相同，但上面這些是 Handbook 給的共通範圍。考題如果問保存溫度，記得是氣相液態氮、負 140 度以下，不是一般冷凍櫃的溫度。</a:t>
+            </a:r>
+          </a:p>
         </p:txBody>
       </p:sp>
       <p:sp>
@@ -1414,6 +1469,17 @@
               <a:t>Colony-forming assay 可以評估造血潛能，但不是放行標準，只用在流程確效，或冷凍超過 5 年的 graft。除了 CD34 以外的細胞亞群和腫瘤污染，平常也不驗，只在臨床試驗做。70% 和 3 支這兩個數字，可以和前一張的冷凍條件一起記。</a:t>
             </a:r>
           </a:p>
+          <a:p>
+            <a:pPr>
+              <a:spcAft>
+                <a:spcPts val="600"/>
+              </a:spcAft>
+            </a:pPr>
+            <a:r>
+              <a:rPr lang="en-US" dirty="0"/>
+              <a:t>這張最好和第 16 章的 CD34 門檻一起記，2 × 10⁶/kg 同時是收集目標和放行標準。時間欄也很重要，CD34、細胞數和紅血球是收集後馬上驗，培養在冷凍前採，viability 則是解凍後才驗，所以品質檢驗分散在流程的不同時間點完成。</a:t>
+            </a:r>
+          </a:p>
         </p:txBody>
       </p:sp>
       <p:sp>
@@ -1535,6 +1601,28 @@
               </a:spcAft>
             </a:pPr>
             <a:r>
+              <a:rPr lang="en-US" dirty="0"/>
+              <a:t>提示一下，這題同時考 graft source 的選擇和 harvest 的技術細節，五個選項各對應一個觀念。</a:t>
+            </a:r>
+          </a:p>
+          <a:p>
+            <a:pPr>
+              <a:spcAft>
+                <a:spcPts val="600"/>
+              </a:spcAft>
+            </a:pPr>
+            <a:r>
+              <a:rPr lang="en-US" dirty="0"/>
+              <a:t>題目刻意給了妹妹的體重，可以順便算一下抽取量的上限。</a:t>
+            </a:r>
+          </a:p>
+          <a:p>
+            <a:pPr>
+              <a:spcAft>
+                <a:spcPts val="600"/>
+              </a:spcAft>
+            </a:pPr>
+            <a:r>
               <a:rPr lang="en-US" b="1" dirty="0"/>
               <a:t>[Pause for answers.]</a:t>
             </a:r>
@@ -1774,6 +1862,28 @@
               </a:spcAft>
             </a:pPr>
             <a:r>
+              <a:rPr lang="en-US" dirty="0"/>
+              <a:t>再想病人有沒有 predicted poor mobiliser 的因素，以及 G-CSF 還能延長多久。</a:t>
+            </a:r>
+          </a:p>
+          <a:p>
+            <a:pPr>
+              <a:spcAft>
+                <a:spcPts val="600"/>
+              </a:spcAft>
+            </a:pPr>
+            <a:r>
+              <a:rPr lang="en-US" dirty="0"/>
+              <a:t>題目特別寫出 induction 用了什麼藥，這個細節不是隨便放的。</a:t>
+            </a:r>
+          </a:p>
+          <a:p>
+            <a:pPr>
+              <a:spcAft>
+                <a:spcPts val="600"/>
+              </a:spcAft>
+            </a:pPr>
+            <a:r>
               <a:rPr lang="en-US" b="1" dirty="0"/>
               <a:t>[Pause for answers.]</a:t>
             </a:r>
@@ -1892,6 +2002,17 @@
               <a:t>A 不對，8/µL 遠低於開始 apheresis 的 20/µL，直接收很可能連一次的量都不夠，而他需要兩次的量，還必須在第一次 high-dose therapy 前收齊。C 的問題是 G-CSF 只能多打一到兩天。D 單用 G-CSF 再試一次成功率更低。E 太早放棄，plerixafor 救回來的機會很高。</a:t>
             </a:r>
           </a:p>
+          <a:p>
+            <a:pPr>
+              <a:spcAft>
+                <a:spcPts val="600"/>
+              </a:spcAft>
+            </a:pPr>
+            <a:r>
+              <a:rPr lang="en-US" dirty="0"/>
+              <a:t>這題也提醒，plerixafor 越早在對的時間點加，apheresis 次數越少，總成本反而越低。</a:t>
+            </a:r>
+          </a:p>
         </p:txBody>
       </p:sp>
       <p:sp>
@@ -2017,6 +2138,17 @@
               <a:t>第三段處理收不到的人，也就是 poor mobiliser 和 plerixafor 的使用時機，然後是收到之後怎麼冷凍保存、什麼條件下這袋 graft 才能放行。最後三題，分別對應這三段。</a:t>
             </a:r>
           </a:p>
+          <a:p>
+            <a:pPr>
+              <a:spcAft>
+                <a:spcPts val="600"/>
+              </a:spcAft>
+            </a:pPr>
+            <a:r>
+              <a:rPr lang="en-US" dirty="0"/>
+              <a:t>這三段剛好照著一袋 graft 的生命週期走，從捐贈者身上取出、收集、冷凍，到放行輸回病人。每一段的數字不多，但每一個都可能直接變成選項。</a:t>
+            </a:r>
+          </a:p>
         </p:txBody>
       </p:sp>
       <p:sp>
@@ -2138,6 +2270,28 @@
               </a:spcAft>
             </a:pPr>
             <a:r>
+              <a:rPr lang="en-US" dirty="0"/>
+              <a:t>五個數字都在剛才的表上，請逐一和放行標準對照，也注意冷凍前的等待時間有沒有超過上限。</a:t>
+            </a:r>
+          </a:p>
+          <a:p>
+            <a:pPr>
+              <a:spcAft>
+                <a:spcPts val="600"/>
+              </a:spcAft>
+            </a:pPr>
+            <a:r>
+              <a:rPr lang="en-US" dirty="0"/>
+              <a:t>這題的數字很多，但只有一個超出標準。</a:t>
+            </a:r>
+          </a:p>
+          <a:p>
+            <a:pPr>
+              <a:spcAft>
+                <a:spcPts val="600"/>
+              </a:spcAft>
+            </a:pPr>
+            <a:r>
               <a:rPr lang="en-US" b="1" dirty="0"/>
               <a:t>[Pause for answers.]</a:t>
             </a:r>
@@ -2256,6 +2410,17 @@
               <a:t>最容易選錯的是 A。收集後最多可以放 72 小時再冷凍，建議 48 小時內，40 小時兩個條件都符合。B、C、E 都在標準內。實務上 viability 不足時，要回頭檢查冷凍流程，必要時重新收集。</a:t>
             </a:r>
           </a:p>
+          <a:p>
+            <a:pPr>
+              <a:spcAft>
+                <a:spcPts val="600"/>
+              </a:spcAft>
+            </a:pPr>
+            <a:r>
+              <a:rPr lang="en-US" dirty="0"/>
+              <a:t>這題的教學點是，CD34 數量夠不代表 graft 一定能用，冷凍後的活性一樣是硬性門檻，而這個 70% 是用同條件冷凍的 reference sample 驗出來的。</a:t>
+            </a:r>
+          </a:p>
         </p:txBody>
       </p:sp>
       <p:sp>
@@ -2832,6 +2997,17 @@
               <a:t>第 16 章則提醒 peripheral blood 的好處，捐贈者比較不辛苦，engraftment 比較快。</a:t>
             </a:r>
           </a:p>
+          <a:p>
+            <a:pPr>
+              <a:spcAft>
+                <a:spcPts val="600"/>
+              </a:spcAft>
+            </a:pPr>
+            <a:r>
+              <a:rPr lang="en-US" dirty="0"/>
+              <a:t>考試另一個角度是反過來問，惡性疾病選 marrow 的代價是什麼，就是 GVL 比較弱、relapse 風險比較高。捐贈者那一欄也要記，marrow 不用打 G-CSF；不過書上也註明，短期使用 G-CSF 的捐贈者，至今沒有證實長期血液疾病的風險增加。</a:t>
+            </a:r>
+          </a:p>
         </p:txBody>
       </p:sp>
       <p:sp>
@@ -2968,6 +3144,17 @@
               <a:t>抗凝劑多數中心用 heparin。若 marrow 要運送到別的中心或要冷凍，JACIE 和 AABB 都建議再加 10% ACD-A，避免結塊。</a:t>
             </a:r>
           </a:p>
+          <a:p>
+            <a:pPr>
+              <a:spcAft>
+                <a:spcPts val="600"/>
+              </a:spcAft>
+            </a:pPr>
+            <a:r>
+              <a:rPr lang="en-US" dirty="0"/>
+              <a:t>多孔針雖然方便，但血液污染更多。每抽完一管，用含 heparin 的生理食鹽水沖洗針筒，收集袋要定期輕搖，避免凝塊。這些細節考得少，但說明了 harvest 的品質為什麼和操作者的經驗很有關係。</a:t>
+            </a:r>
+          </a:p>
         </p:txBody>
       </p:sp>
       <p:sp>
@@ -3093,6 +3280,17 @@
               <a:t>CD34 雖然會驗，但不是 marrow 的標準指標。近年 harvest 的細胞濃度在下降，原因是每年少於 6 例的中心經驗不足，以及為了縮短麻醉時間抽得太快太大量。冷凍會讓細胞流失，一般影響不大，但在 aplastic anaemia 有不利的報告，所以除非必要，marrow 不冷凍。</a:t>
             </a:r>
           </a:p>
+          <a:p>
+            <a:pPr>
+              <a:spcAft>
+                <a:spcPts val="600"/>
+              </a:spcAft>
+            </a:pPr>
+            <a:r>
+              <a:rPr lang="en-US" dirty="0"/>
+              <a:t>COVID-19 期間，很多 unrelated donor 的 marrow 必須冷凍再運送，運送延遲和冷凍造成的細胞流失才又被重新重視。</a:t>
+            </a:r>
+          </a:p>
         </p:txBody>
       </p:sp>
       <p:sp>
@@ -3229,6 +3427,17 @@
               <a:t>輸血策略寫在下面。書上推薦不輸血、只補充液體，次選是兩到三週前先存的自體血，健康捐贈者絕對避免輸別人的血。術後一週止痛、口服鐵劑，七天內避免劇烈運動和提重物。</a:t>
             </a:r>
           </a:p>
+          <a:p>
+            <a:pPr>
+              <a:spcAft>
+                <a:spcPts val="600"/>
+              </a:spcAft>
+            </a:pPr>
+            <a:r>
+              <a:rPr lang="en-US" dirty="0"/>
+              <a:t>慢性疼痛的 5%，反而是捐贈者最可能遇到的問題，做 donor counselling 時要特別說明。Major complication 雖然少，多半和麻醉有關，所以入院前的麻醉前評估是 harvest 流程的固定項目。</a:t>
+            </a:r>
+          </a:p>
         </p:txBody>
       </p:sp>
       <p:sp>
@@ -3365,6 +3574,17 @@
               <a:t>Steady state 可以門診做、時間好預測、便宜；化療加 G-CSF 收得多、apheresis 次數少，還能壓腫瘤，但要住院、傷骨髓、影響以後再收。兩者 relapse rate 相當。Myeloma 或穩定緩解用 steady state，還需要降腫瘤量的就一起化療。</a:t>
             </a:r>
           </a:p>
+          <a:p>
+            <a:pPr>
+              <a:spcAft>
+                <a:spcPts val="600"/>
+              </a:spcAft>
+            </a:pPr>
+            <a:r>
+              <a:rPr lang="en-US" dirty="0"/>
+              <a:t>選擇的關鍵不在哪一種收得多，而是病人本來還需不需要化療。化療後什麼時候開始驗 CD34，下一張詳細列出。</a:t>
+            </a:r>
+          </a:p>
         </p:txBody>
       </p:sp>
       <p:sp>
@@ -3501,6 +3721,17 @@
               <a:t>周邊血 CD34 超過 20/µL 就開始 apheresis。這個 20 是整個 mobilisation 最重要的數字，等一下 plerixafor 的流程也從這裡出發。</a:t>
             </a:r>
           </a:p>
+          <a:p>
+            <a:pPr>
+              <a:spcAft>
+                <a:spcPts val="600"/>
+              </a:spcAft>
+            </a:pPr>
+            <a:r>
+              <a:rPr lang="en-US" dirty="0"/>
+              <a:t>不必死背每一格，記得骨髓抑制越深的 regimen 越晚開始，像 DHAP 和 CAD 都是第 9 天才開始 G-CSF，第 13 到 14 天才開始驗。</a:t>
+            </a:r>
+          </a:p>
         </p:txBody>
       </p:sp>
       <p:sp>
@@ -3635,6 +3866,17 @@
             <a:r>
               <a:rPr lang="en-US" dirty="0"/>
               <a:t>第 41 章 graft failure 的表把 auto 最低值寫成 1 × 10⁶，跟這兩章不一致，考試以 2 × 10⁶ 為準。</a:t>
+            </a:r>
+          </a:p>
+          <a:p>
+            <a:pPr>
+              <a:spcAft>
+                <a:spcPts val="600"/>
+              </a:spcAft>
+            </a:pPr>
+            <a:r>
+              <a:rPr lang="en-US" dirty="0"/>
+              <a:t>這個 cGVHD 的資料來自 HLA-identical sibling 的 peripheral blood graft。考題如果問 allo 的 CD34 是不是越多越好，答案是否定的。</a:t>
             </a:r>
           </a:p>
           <a:p>

</xml_diff>

<commit_message>
Slides: sessions in progress; ignore office lock files
Co-Authored-By: Claude Opus 5.5 <noreply@anthropic.com>
Claude-Session: https://claude.ai/code/session_01XkzKv8pUGMF9AsqSCMpnBq
</commit_message>
<xml_diff>
--- a/slides/decks/s04-mobilisation-collection.pptx
+++ b/slides/decks/s04-mobilisation-collection.pptx
@@ -132,13 +132,13 @@
   <p:extLst>
     <p:ext uri="{521415D9-36F7-43E2-AB2F-B90AF26B5E84}">
       <p14:sectionLst xmlns:p14="http://schemas.microsoft.com/office/powerpoint/2010/main">
-        <p14:section name="Opening" id="{da2a56c5-b8a7-93ed-356c-9c0b052d31ab}">
+        <p14:section name="Opening" id="{17e1c3d8-4de7-f631-db09-e1d142fae496}">
           <p14:sldIdLst>
             <p14:sldId id="256"/>
             <p14:sldId id="257"/>
           </p14:sldIdLst>
         </p14:section>
-        <p14:section name="Bone marrow harvest" id="{757acd5d-d222-59f2-9d75-33221843e464}">
+        <p14:section name="Bone marrow harvest" id="{63226575-6867-46bb-a1df-133e2357b954}">
           <p14:sldIdLst>
             <p14:sldId id="258"/>
             <p14:sldId id="259"/>
@@ -146,7 +146,7 @@
             <p14:sldId id="261"/>
           </p14:sldIdLst>
         </p14:section>
-        <p14:section name="Mobilisation and apheresis" id="{e2f837b7-75fa-b493-d95b-a81a65c7524c}">
+        <p14:section name="Mobilisation and apheresis" id="{b060260f-8af6-5f89-1dcd-29b4f64bfe63}">
           <p14:sldIdLst>
             <p14:sldId id="262"/>
             <p14:sldId id="263"/>
@@ -154,7 +154,7 @@
             <p14:sldId id="265"/>
           </p14:sldIdLst>
         </p14:section>
-        <p14:section name="Poor mobilisers, freezing and release" id="{ab361bbf-4a15-15af-c93e-9c9a6af14d20}">
+        <p14:section name="Poor mobilisers, freezing and release" id="{e561b877-bd01-4e19-0728-b435e4d030df}">
           <p14:sldIdLst>
             <p14:sldId id="266"/>
             <p14:sldId id="267"/>
@@ -163,7 +163,7 @@
             <p14:sldId id="270"/>
           </p14:sldIdLst>
         </p14:section>
-        <p14:section name="Board questions" id="{a3458912-8e2e-5813-c529-ffb96a580f6f}">
+        <p14:section name="Board questions" id="{9bd5f541-0880-d4d4-344f-e171cfc8a834}">
           <p14:sldIdLst>
             <p14:sldId id="271"/>
             <p14:sldId id="272"/>
@@ -173,13 +173,13 @@
             <p14:sldId id="276"/>
           </p14:sldIdLst>
         </p14:section>
-        <p14:section name="References" id="{89389930-ab0d-135f-7910-f638997683c6}">
+        <p14:section name="References" id="{79a4fecd-15d0-5d9a-6345-59ff3c23447b}">
           <p14:sldIdLst>
             <p14:sldId id="277"/>
             <p14:sldId id="278"/>
           </p14:sldIdLst>
         </p14:section>
-        <p14:section name="Backup" id="{c0a2ae86-ad4a-6864-badc-05fb21ed5c6f}">
+        <p14:section name="Backup" id="{2acf2bf3-59cc-03a7-c5aa-86ab732374a1}">
           <p14:sldIdLst>
             <p14:sldId id="279"/>
             <p14:sldId id="280"/>
@@ -8067,7 +8067,7 @@
                   <a:schemeClr val="tx1"/>
                 </a:solidFill>
               </a:rPr>
-              <a:t>G-CSF fails in 5–10%. Plerixafor is not approved for donors, yet adding it raised CD34+ about three-fold</a:t>
+              <a:t>G-CSF fails in 5–10%. Plerixafor is not approved for donors, yet adding it gave roughly 3-fold more CD34+ cells</a:t>
             </a:r>
             <a:endParaRPr lang="en-US" sz="1800" dirty="0"/>
           </a:p>
@@ -8377,7 +8377,21 @@
                   <a:schemeClr val="tx1"/>
                 </a:solidFill>
               </a:rPr>
-              <a:t>Hold ≤ 72 h at 2–6 °C</a:t>
+              <a:t>Hold ≤ 72 h</a:t>
+            </a:r>
+            <a:endParaRPr lang="en-US" sz="1500" dirty="0"/>
+          </a:p>
+          <a:p>
+            <a:pPr algn="ctr" indent="0" marL="0">
+              <a:buNone/>
+            </a:pPr>
+            <a:r>
+              <a:rPr lang="en-US" sz="1500" dirty="0">
+                <a:solidFill>
+                  <a:schemeClr val="tx1"/>
+                </a:solidFill>
+              </a:rPr>
+              <a:t>at 2–6 °C</a:t>
             </a:r>
             <a:endParaRPr lang="en-US" sz="1500" dirty="0"/>
           </a:p>
@@ -8443,7 +8457,21 @@
                   <a:schemeClr val="tx1"/>
                 </a:solidFill>
               </a:rPr>
-              <a:t>NC ≤ 4 × 10⁸/mL; DMSO 5–10%</a:t>
+              <a:t>NC ≤ 4 × 10⁸/mL</a:t>
+            </a:r>
+            <a:endParaRPr lang="en-US" sz="1500" dirty="0"/>
+          </a:p>
+          <a:p>
+            <a:pPr algn="ctr" indent="0" marL="0">
+              <a:buNone/>
+            </a:pPr>
+            <a:r>
+              <a:rPr lang="en-US" sz="1500" dirty="0">
+                <a:solidFill>
+                  <a:schemeClr val="tx1"/>
+                </a:solidFill>
+              </a:rPr>
+              <a:t>DMSO 5–10%</a:t>
             </a:r>
             <a:endParaRPr lang="en-US" sz="1500" dirty="0"/>
           </a:p>
@@ -8509,7 +8537,21 @@
                   <a:schemeClr val="tx1"/>
                 </a:solidFill>
               </a:rPr>
-              <a:t>Controlled rate 1–2 °C/min</a:t>
+              <a:t>Controlled rate</a:t>
+            </a:r>
+            <a:endParaRPr lang="en-US" sz="1500" dirty="0"/>
+          </a:p>
+          <a:p>
+            <a:pPr algn="ctr" indent="0" marL="0">
+              <a:buNone/>
+            </a:pPr>
+            <a:r>
+              <a:rPr lang="en-US" sz="1500" dirty="0">
+                <a:solidFill>
+                  <a:schemeClr val="tx1"/>
+                </a:solidFill>
+              </a:rPr>
+              <a:t>1–2 °C/min</a:t>
             </a:r>
             <a:endParaRPr lang="en-US" sz="1500" dirty="0"/>
           </a:p>
@@ -8575,7 +8617,21 @@
                   <a:schemeClr val="tx1"/>
                 </a:solidFill>
               </a:rPr>
-              <a:t>Vapour-phase N₂ ≤ −140 °C</a:t>
+              <a:t>Vapour-phase N₂</a:t>
+            </a:r>
+            <a:endParaRPr lang="en-US" sz="1500" dirty="0"/>
+          </a:p>
+          <a:p>
+            <a:pPr algn="ctr" indent="0" marL="0">
+              <a:buNone/>
+            </a:pPr>
+            <a:r>
+              <a:rPr lang="en-US" sz="1500" dirty="0">
+                <a:solidFill>
+                  <a:schemeClr val="tx1"/>
+                </a:solidFill>
+              </a:rPr>
+              <a:t>≤ −140 °C</a:t>
             </a:r>
             <a:endParaRPr lang="en-US" sz="1500" dirty="0"/>
           </a:p>
@@ -8641,7 +8697,21 @@
                   <a:schemeClr val="bg1"/>
                 </a:solidFill>
               </a:rPr>
-              <a:t>Thaw at bedside, infuse ≤ 20 min</a:t>
+              <a:t>Thaw at bedside,</a:t>
+            </a:r>
+            <a:endParaRPr lang="en-US" sz="1500" dirty="0"/>
+          </a:p>
+          <a:p>
+            <a:pPr algn="ctr" indent="0" marL="0">
+              <a:buNone/>
+            </a:pPr>
+            <a:r>
+              <a:rPr lang="en-US" sz="1500" dirty="0">
+                <a:solidFill>
+                  <a:schemeClr val="bg1"/>
+                </a:solidFill>
+              </a:rPr>
+              <a:t>infuse ≤ 20 min</a:t>
             </a:r>
             <a:endParaRPr lang="en-US" sz="1500" dirty="0"/>
           </a:p>
@@ -8823,7 +8893,7 @@
                   <a:schemeClr val="tx1"/>
                 </a:solidFill>
               </a:rPr>
-              <a:t>An autograft is released only if it meets five criteria</a:t>
+              <a:t>An autograft is released only when it meets all five criteria</a:t>
             </a:r>
             <a:endParaRPr lang="en-US" sz="3600" dirty="0"/>
           </a:p>
@@ -15132,7 +15202,7 @@
                   <a:schemeClr val="tx1"/>
                 </a:solidFill>
               </a:rPr>
-              <a:t>Marrow trades slower recovery for less chronic GVHD</a:t>
+              <a:t>Marrow grafts engraft more slowly but cause less chronic GVHD</a:t>
             </a:r>
             <a:endParaRPr lang="en-US" sz="3600" dirty="0"/>
           </a:p>
@@ -18402,7 +18472,7 @@
                   <a:schemeClr val="tx1"/>
                 </a:solidFill>
               </a:rPr>
-              <a:t>Transfusion: fluid replacement preferred, autologous blood second-best; never allogeneic blood in a healthy donor</a:t>
+              <a:t>Donor transfusion: fluids first, autologous blood second, never allogeneic blood</a:t>
             </a:r>
             <a:endParaRPr lang="en-US" sz="1600" dirty="0"/>
           </a:p>

</xml_diff>

<commit_message>
Slides: session 15 pulmonary; others in progress
Co-Authored-By: Claude Opus 5.5 <noreply@anthropic.com>
Claude-Session: https://claude.ai/code/session_01XkzKv8pUGMF9AsqSCMpnBq
</commit_message>
<xml_diff>
--- a/slides/decks/s04-mobilisation-collection.pptx
+++ b/slides/decks/s04-mobilisation-collection.pptx
@@ -132,13 +132,13 @@
   <p:extLst>
     <p:ext uri="{521415D9-36F7-43E2-AB2F-B90AF26B5E84}">
       <p14:sectionLst xmlns:p14="http://schemas.microsoft.com/office/powerpoint/2010/main">
-        <p14:section name="Opening" id="{17e1c3d8-4de7-f631-db09-e1d142fae496}">
+        <p14:section name="Opening" id="{c7584b6e-960f-2af6-74b6-7b9ae7af918f}">
           <p14:sldIdLst>
             <p14:sldId id="256"/>
             <p14:sldId id="257"/>
           </p14:sldIdLst>
         </p14:section>
-        <p14:section name="Bone marrow harvest" id="{63226575-6867-46bb-a1df-133e2357b954}">
+        <p14:section name="Bone marrow harvest" id="{674c3892-1273-2998-12da-406a46a1d59d}">
           <p14:sldIdLst>
             <p14:sldId id="258"/>
             <p14:sldId id="259"/>
@@ -146,7 +146,7 @@
             <p14:sldId id="261"/>
           </p14:sldIdLst>
         </p14:section>
-        <p14:section name="Mobilisation and apheresis" id="{b060260f-8af6-5f89-1dcd-29b4f64bfe63}">
+        <p14:section name="Mobilisation and apheresis" id="{d8ee6e48-f29e-c620-4086-e1f4ee6cc375}">
           <p14:sldIdLst>
             <p14:sldId id="262"/>
             <p14:sldId id="263"/>
@@ -154,7 +154,7 @@
             <p14:sldId id="265"/>
           </p14:sldIdLst>
         </p14:section>
-        <p14:section name="Poor mobilisers, freezing and release" id="{e561b877-bd01-4e19-0728-b435e4d030df}">
+        <p14:section name="Poor mobilisers, freezing and release" id="{7cb9fdd7-cac4-c937-7e57-c099cb796764}">
           <p14:sldIdLst>
             <p14:sldId id="266"/>
             <p14:sldId id="267"/>
@@ -163,7 +163,7 @@
             <p14:sldId id="270"/>
           </p14:sldIdLst>
         </p14:section>
-        <p14:section name="Board questions" id="{9bd5f541-0880-d4d4-344f-e171cfc8a834}">
+        <p14:section name="Board questions" id="{8d87e6b2-64a6-79a1-9eaf-b2b095efafdc}">
           <p14:sldIdLst>
             <p14:sldId id="271"/>
             <p14:sldId id="272"/>
@@ -173,13 +173,13 @@
             <p14:sldId id="276"/>
           </p14:sldIdLst>
         </p14:section>
-        <p14:section name="References" id="{79a4fecd-15d0-5d9a-6345-59ff3c23447b}">
+        <p14:section name="References" id="{184c1a5c-7f65-d951-4de7-9262b2868a10}">
           <p14:sldIdLst>
             <p14:sldId id="277"/>
             <p14:sldId id="278"/>
           </p14:sldIdLst>
         </p14:section>
-        <p14:section name="Backup" id="{2acf2bf3-59cc-03a7-c5aa-86ab732374a1}">
+        <p14:section name="Backup" id="{85ca4f60-f5da-1644-c760-955d4446ddf8}">
           <p14:sldIdLst>
             <p14:sldId id="279"/>
             <p14:sldId id="280"/>
@@ -18450,7 +18450,7 @@
         </p:nvSpPr>
         <p:spPr>
           <a:xfrm>
-            <a:off x="685800" y="5257800"/>
+            <a:off x="685800" y="5349240"/>
             <a:ext cx="10817352" cy="411480"/>
           </a:xfrm>
           <a:prstGeom prst="rect">

</xml_diff>